<commit_message>
fix(web): hardened backend proxy against empty NEXT_PUBLIC_API_URL
Proxy now falls back to the production API URL when the Vercel env var
is blank/quoted, and returns a controlled 502 instead of a bare 500
when the upstream fetch fails. Root cause of the intermittent login
failures is the Render free-plan API service restarting unpredictably
(confirmed via Render + Vercel logs), not this proxy or the database.
</commit_message>
<xml_diff>
--- a/comercial/Evenflow_Deck_Comercial.pptx
+++ b/comercial/Evenflow_Deck_Comercial.pptx
@@ -951,7 +951,7 @@
           <a:p>
             <a:r>
               <a:rPr lang="en-US" dirty="0"/>
-              <a:t>Demonstrar ao vivo: ler um QR Code válido e repetir a leitura para mostrar o bloqueio de duplicidade. Nunca usar ingresso de cliente real.</a:t>
+              <a:t>O print mostra a recusa por ingresso de outro evento. Na demonstração ao vivo, leia um QR válido e repita a leitura para mostrar também o bloqueio de duplicidade. Nunca usar ingresso de cliente real.</a:t>
             </a:r>
             <a:endParaRPr lang="en-US" dirty="0"/>
           </a:p>
@@ -3995,95 +3995,92 @@
           </a:p>
         </p:txBody>
       </p:sp>
-      <p:sp>
-        <p:nvSpPr>
-          <p:cNvPr id="5" name="Shape 3"/>
+      <p:pic>
+        <p:nvPicPr>
+          <p:cNvPr id="5" name="Image 0" descr="shots/c_evento.png">    </p:cNvPr>
+          <p:cNvPicPr>
+            <a:picLocks noChangeAspect="1"/>
+          </p:cNvPicPr>
+          <p:nvPr/>
+        </p:nvPicPr>
+        <p:blipFill>
+          <a:blip r:embed="rId1"/>
+          <a:stretch>
+            <a:fillRect/>
+          </a:stretch>
+        </p:blipFill>
+        <p:spPr>
+          <a:xfrm>
+            <a:off x="818365" y="2286000"/>
+            <a:ext cx="3155914" cy="2606040"/>
+          </a:xfrm>
+          <a:prstGeom prst="rect">
+            <a:avLst/>
+          </a:prstGeom>
+        </p:spPr>
+      </p:pic>
+      <p:sp>
+        <p:nvSpPr>
+          <p:cNvPr id="6" name="Shape 3"/>
           <p:cNvSpPr/>
           <p:nvPr/>
         </p:nvSpPr>
         <p:spPr>
           <a:xfrm>
-            <a:off x="685800" y="2212848"/>
-            <a:ext cx="3310128" cy="2834640"/>
-          </a:xfrm>
-          <a:prstGeom prst="roundRect">
-            <a:avLst>
-              <a:gd name="adj" fmla="val 1935"/>
-            </a:avLst>
-          </a:prstGeom>
-          <a:solidFill>
-            <a:srgbClr val="13101D"/>
-          </a:solidFill>
+            <a:off x="818365" y="2286000"/>
+            <a:ext cx="3155914" cy="2606040"/>
+          </a:xfrm>
+          <a:prstGeom prst="rect">
+            <a:avLst/>
+          </a:prstGeom>
           <a:ln w="12700">
             <a:solidFill>
-              <a:srgbClr val="2A2440"/>
+              <a:srgbClr val="2E2552"/>
             </a:solidFill>
-            <a:prstDash val="dash"/>
+            <a:prstDash val="solid"/>
           </a:ln>
         </p:spPr>
       </p:sp>
       <p:sp>
         <p:nvSpPr>
-          <p:cNvPr id="6" name="Text 4"/>
-          <p:cNvSpPr txBox="1"/>
-          <p:nvPr/>
-        </p:nvSpPr>
-        <p:spPr>
-          <a:xfrm>
-            <a:off x="850392" y="3246120"/>
-            <a:ext cx="2980944" cy="768096"/>
-          </a:xfrm>
-          <a:prstGeom prst="rect">
-            <a:avLst/>
-          </a:prstGeom>
-          <a:noFill/>
-          <a:ln/>
-        </p:spPr>
-        <p:txBody>
-          <a:bodyPr wrap="square" lIns="0" tIns="0" rIns="0" bIns="0" rtlCol="0" anchor="ctr"/>
-          <a:lstStyle/>
-          <a:p>
-            <a:pPr algn="ctr" indent="0" marL="0">
+          <p:cNvPr id="7" name="Text 4"/>
+          <p:cNvSpPr txBox="1"/>
+          <p:nvPr/>
+        </p:nvSpPr>
+        <p:spPr>
+          <a:xfrm>
+            <a:off x="818365" y="5010912"/>
+            <a:ext cx="3155914" cy="566928"/>
+          </a:xfrm>
+          <a:prstGeom prst="rect">
+            <a:avLst/>
+          </a:prstGeom>
+          <a:noFill/>
+          <a:ln/>
+        </p:spPr>
+        <p:txBody>
+          <a:bodyPr wrap="square" lIns="0" tIns="0" rIns="0" bIns="0" rtlCol="0" anchor="t"/>
+          <a:lstStyle/>
+          <a:p>
+            <a:pPr indent="0" marL="0">
               <a:lnSpc>
                 <a:spcPct val="120000"/>
               </a:lnSpc>
               <a:buNone/>
             </a:pPr>
             <a:r>
-              <a:rPr lang="en-US" sz="1150" dirty="0">
-                <a:solidFill>
-                  <a:srgbClr val="6E6689"/>
-                </a:solidFill>
-                <a:latin typeface="Calibri" pitchFamily="34" charset="0"/>
-                <a:ea typeface="Calibri" pitchFamily="34" charset="-122"/>
-                <a:cs typeface="Calibri" pitchFamily="34" charset="-120"/>
-              </a:rPr>
-              <a:t>inserir print 1</a:t>
-            </a:r>
-            <a:endParaRPr lang="en-US" sz="1150" dirty="0"/>
-          </a:p>
-        </p:txBody>
-      </p:sp>
-      <p:sp>
-        <p:nvSpPr>
-          <p:cNvPr id="7" name="Text 5"/>
-          <p:cNvSpPr txBox="1"/>
-          <p:nvPr/>
-        </p:nvSpPr>
-        <p:spPr>
-          <a:xfrm>
-            <a:off x="685800" y="5175504"/>
-            <a:ext cx="3310128" cy="566928"/>
-          </a:xfrm>
-          <a:prstGeom prst="rect">
-            <a:avLst/>
-          </a:prstGeom>
-          <a:noFill/>
-          <a:ln/>
-        </p:spPr>
-        <p:txBody>
-          <a:bodyPr wrap="square" lIns="0" tIns="0" rIns="0" bIns="0" rtlCol="0" anchor="ctr"/>
-          <a:lstStyle/>
+              <a:rPr lang="en-US" sz="1200" dirty="0">
+                <a:solidFill>
+                  <a:srgbClr val="F5F2FF"/>
+                </a:solidFill>
+                <a:latin typeface="Calibri" pitchFamily="34" charset="0"/>
+                <a:ea typeface="Calibri" pitchFamily="34" charset="-122"/>
+                <a:cs typeface="Calibri" pitchFamily="34" charset="-120"/>
+              </a:rPr>
+              <a:t>Escolha do lote</a:t>
+            </a:r>
+            <a:endParaRPr lang="en-US" sz="1200" dirty="0"/>
+          </a:p>
           <a:p>
             <a:pPr indent="0" marL="0">
               <a:lnSpc>
@@ -4092,7 +4089,7 @@
               <a:buNone/>
             </a:pPr>
             <a:r>
-              <a:rPr lang="en-US" sz="1250" dirty="0">
+              <a:rPr lang="en-US" sz="1200" dirty="0">
                 <a:solidFill>
                   <a:srgbClr val="F5F2FF"/>
                 </a:solidFill>
@@ -4100,10 +4097,78 @@
                 <a:ea typeface="Calibri" pitchFamily="34" charset="-122"/>
                 <a:cs typeface="Calibri" pitchFamily="34" charset="-120"/>
               </a:rPr>
-              <a:t>Página do evento</a:t>
-            </a:r>
-            <a:endParaRPr lang="en-US" sz="1250" dirty="0"/>
-          </a:p>
+              <a:t>na página do evento</a:t>
+            </a:r>
+            <a:endParaRPr lang="en-US" sz="1200" dirty="0"/>
+          </a:p>
+        </p:txBody>
+      </p:sp>
+      <p:pic>
+        <p:nvPicPr>
+          <p:cNvPr id="8" name="Image 1" descr="shots/c_checkout.png">    </p:cNvPr>
+          <p:cNvPicPr>
+            <a:picLocks noChangeAspect="1"/>
+          </p:cNvPicPr>
+          <p:nvPr/>
+        </p:nvPicPr>
+        <p:blipFill>
+          <a:blip r:embed="rId2"/>
+          <a:stretch>
+            <a:fillRect/>
+          </a:stretch>
+        </p:blipFill>
+        <p:spPr>
+          <a:xfrm>
+            <a:off x="4294320" y="2286000"/>
+            <a:ext cx="3135066" cy="2606040"/>
+          </a:xfrm>
+          <a:prstGeom prst="rect">
+            <a:avLst/>
+          </a:prstGeom>
+        </p:spPr>
+      </p:pic>
+      <p:sp>
+        <p:nvSpPr>
+          <p:cNvPr id="9" name="Shape 5"/>
+          <p:cNvSpPr/>
+          <p:nvPr/>
+        </p:nvSpPr>
+        <p:spPr>
+          <a:xfrm>
+            <a:off x="4294320" y="2286000"/>
+            <a:ext cx="3135066" cy="2606040"/>
+          </a:xfrm>
+          <a:prstGeom prst="rect">
+            <a:avLst/>
+          </a:prstGeom>
+          <a:ln w="12700">
+            <a:solidFill>
+              <a:srgbClr val="2E2552"/>
+            </a:solidFill>
+            <a:prstDash val="solid"/>
+          </a:ln>
+        </p:spPr>
+      </p:sp>
+      <p:sp>
+        <p:nvSpPr>
+          <p:cNvPr id="10" name="Text 6"/>
+          <p:cNvSpPr txBox="1"/>
+          <p:nvPr/>
+        </p:nvSpPr>
+        <p:spPr>
+          <a:xfrm>
+            <a:off x="4294320" y="5010912"/>
+            <a:ext cx="3135066" cy="566928"/>
+          </a:xfrm>
+          <a:prstGeom prst="rect">
+            <a:avLst/>
+          </a:prstGeom>
+          <a:noFill/>
+          <a:ln/>
+        </p:spPr>
+        <p:txBody>
+          <a:bodyPr wrap="square" lIns="0" tIns="0" rIns="0" bIns="0" rtlCol="0" anchor="t"/>
+          <a:lstStyle/>
           <a:p>
             <a:pPr indent="0" marL="0">
               <a:lnSpc>
@@ -4112,7 +4177,7 @@
               <a:buNone/>
             </a:pPr>
             <a:r>
-              <a:rPr lang="en-US" sz="1250" dirty="0">
+              <a:rPr lang="en-US" sz="1200" dirty="0">
                 <a:solidFill>
                   <a:srgbClr val="F5F2FF"/>
                 </a:solidFill>
@@ -4120,100 +4185,97 @@
                 <a:ea typeface="Calibri" pitchFamily="34" charset="-122"/>
                 <a:cs typeface="Calibri" pitchFamily="34" charset="-120"/>
               </a:rPr>
-              <a:t>e seleção de lote</a:t>
-            </a:r>
-            <a:endParaRPr lang="en-US" sz="1250" dirty="0"/>
-          </a:p>
-        </p:txBody>
-      </p:sp>
-      <p:sp>
-        <p:nvSpPr>
-          <p:cNvPr id="8" name="Shape 6"/>
-          <p:cNvSpPr/>
-          <p:nvPr/>
-        </p:nvSpPr>
-        <p:spPr>
-          <a:xfrm>
-            <a:off x="4325112" y="2212848"/>
-            <a:ext cx="3310128" cy="2834640"/>
-          </a:xfrm>
-          <a:prstGeom prst="roundRect">
-            <a:avLst>
-              <a:gd name="adj" fmla="val 1935"/>
-            </a:avLst>
-          </a:prstGeom>
-          <a:solidFill>
-            <a:srgbClr val="13101D"/>
-          </a:solidFill>
-          <a:ln w="12700">
-            <a:solidFill>
-              <a:srgbClr val="2A2440"/>
-            </a:solidFill>
-            <a:prstDash val="dash"/>
-          </a:ln>
-        </p:spPr>
-      </p:sp>
-      <p:sp>
-        <p:nvSpPr>
-          <p:cNvPr id="9" name="Text 7"/>
-          <p:cNvSpPr txBox="1"/>
-          <p:nvPr/>
-        </p:nvSpPr>
-        <p:spPr>
-          <a:xfrm>
-            <a:off x="4489704" y="3246120"/>
-            <a:ext cx="2980944" cy="768096"/>
-          </a:xfrm>
-          <a:prstGeom prst="rect">
-            <a:avLst/>
-          </a:prstGeom>
-          <a:noFill/>
-          <a:ln/>
-        </p:spPr>
-        <p:txBody>
-          <a:bodyPr wrap="square" lIns="0" tIns="0" rIns="0" bIns="0" rtlCol="0" anchor="ctr"/>
-          <a:lstStyle/>
-          <a:p>
-            <a:pPr algn="ctr" indent="0" marL="0">
+              <a:t>Checkout com a taxa</a:t>
+            </a:r>
+            <a:endParaRPr lang="en-US" sz="1200" dirty="0"/>
+          </a:p>
+          <a:p>
+            <a:pPr indent="0" marL="0">
               <a:lnSpc>
                 <a:spcPct val="120000"/>
               </a:lnSpc>
               <a:buNone/>
             </a:pPr>
             <a:r>
-              <a:rPr lang="en-US" sz="1150" dirty="0">
-                <a:solidFill>
-                  <a:srgbClr val="6E6689"/>
-                </a:solidFill>
-                <a:latin typeface="Calibri" pitchFamily="34" charset="0"/>
-                <a:ea typeface="Calibri" pitchFamily="34" charset="-122"/>
-                <a:cs typeface="Calibri" pitchFamily="34" charset="-120"/>
-              </a:rPr>
-              <a:t>inserir print 2</a:t>
-            </a:r>
-            <a:endParaRPr lang="en-US" sz="1150" dirty="0"/>
-          </a:p>
-        </p:txBody>
-      </p:sp>
-      <p:sp>
-        <p:nvSpPr>
-          <p:cNvPr id="10" name="Text 8"/>
-          <p:cNvSpPr txBox="1"/>
-          <p:nvPr/>
-        </p:nvSpPr>
-        <p:spPr>
-          <a:xfrm>
-            <a:off x="4325112" y="5175504"/>
-            <a:ext cx="3310128" cy="566928"/>
-          </a:xfrm>
-          <a:prstGeom prst="rect">
-            <a:avLst/>
-          </a:prstGeom>
-          <a:noFill/>
-          <a:ln/>
-        </p:spPr>
-        <p:txBody>
-          <a:bodyPr wrap="square" lIns="0" tIns="0" rIns="0" bIns="0" rtlCol="0" anchor="ctr"/>
+              <a:rPr lang="en-US" sz="1200" dirty="0">
+                <a:solidFill>
+                  <a:srgbClr val="F5F2FF"/>
+                </a:solidFill>
+                <a:latin typeface="Calibri" pitchFamily="34" charset="0"/>
+                <a:ea typeface="Calibri" pitchFamily="34" charset="-122"/>
+                <a:cs typeface="Calibri" pitchFamily="34" charset="-120"/>
+              </a:rPr>
+              <a:t>de 8% na tela</a:t>
+            </a:r>
+            <a:endParaRPr lang="en-US" sz="1200" dirty="0"/>
+          </a:p>
+        </p:txBody>
+      </p:sp>
+      <p:pic>
+        <p:nvPicPr>
+          <p:cNvPr id="11" name="Image 2" descr="shots/c_ingresso.png">    </p:cNvPr>
+          <p:cNvPicPr>
+            <a:picLocks noChangeAspect="1"/>
+          </p:cNvPicPr>
+          <p:nvPr/>
+        </p:nvPicPr>
+        <p:blipFill>
+          <a:blip r:embed="rId3"/>
+          <a:stretch>
+            <a:fillRect/>
+          </a:stretch>
+        </p:blipFill>
+        <p:spPr>
+          <a:xfrm>
+            <a:off x="7749426" y="2286000"/>
+            <a:ext cx="3593729" cy="2606040"/>
+          </a:xfrm>
+          <a:prstGeom prst="rect">
+            <a:avLst/>
+          </a:prstGeom>
+        </p:spPr>
+      </p:pic>
+      <p:sp>
+        <p:nvSpPr>
+          <p:cNvPr id="12" name="Shape 7"/>
+          <p:cNvSpPr/>
+          <p:nvPr/>
+        </p:nvSpPr>
+        <p:spPr>
+          <a:xfrm>
+            <a:off x="7749426" y="2286000"/>
+            <a:ext cx="3593729" cy="2606040"/>
+          </a:xfrm>
+          <a:prstGeom prst="rect">
+            <a:avLst/>
+          </a:prstGeom>
+          <a:ln w="12700">
+            <a:solidFill>
+              <a:srgbClr val="2E2552"/>
+            </a:solidFill>
+            <a:prstDash val="solid"/>
+          </a:ln>
+        </p:spPr>
+      </p:sp>
+      <p:sp>
+        <p:nvSpPr>
+          <p:cNvPr id="13" name="Text 8"/>
+          <p:cNvSpPr txBox="1"/>
+          <p:nvPr/>
+        </p:nvSpPr>
+        <p:spPr>
+          <a:xfrm>
+            <a:off x="7749426" y="5010912"/>
+            <a:ext cx="3593729" cy="566928"/>
+          </a:xfrm>
+          <a:prstGeom prst="rect">
+            <a:avLst/>
+          </a:prstGeom>
+          <a:noFill/>
+          <a:ln/>
+        </p:spPr>
+        <p:txBody>
+          <a:bodyPr wrap="square" lIns="0" tIns="0" rIns="0" bIns="0" rtlCol="0" anchor="t"/>
           <a:lstStyle/>
           <a:p>
             <a:pPr indent="0" marL="0">
@@ -4223,7 +4285,7 @@
               <a:buNone/>
             </a:pPr>
             <a:r>
-              <a:rPr lang="en-US" sz="1250" dirty="0">
+              <a:rPr lang="en-US" sz="1200" dirty="0">
                 <a:solidFill>
                   <a:srgbClr val="F5F2FF"/>
                 </a:solidFill>
@@ -4231,9 +4293,9 @@
                 <a:ea typeface="Calibri" pitchFamily="34" charset="-122"/>
                 <a:cs typeface="Calibri" pitchFamily="34" charset="-120"/>
               </a:rPr>
-              <a:t>Checkout e confirmação</a:t>
-            </a:r>
-            <a:endParaRPr lang="en-US" sz="1250" dirty="0"/>
+              <a:t>Ingresso digital,</a:t>
+            </a:r>
+            <a:endParaRPr lang="en-US" sz="1200" dirty="0"/>
           </a:p>
           <a:p>
             <a:pPr indent="0" marL="0">
@@ -4243,7 +4305,7 @@
               <a:buNone/>
             </a:pPr>
             <a:r>
-              <a:rPr lang="en-US" sz="1250" dirty="0">
+              <a:rPr lang="en-US" sz="1200" dirty="0">
                 <a:solidFill>
                   <a:srgbClr val="F5F2FF"/>
                 </a:solidFill>
@@ -4251,49 +4313,22 @@
                 <a:ea typeface="Calibri" pitchFamily="34" charset="-122"/>
                 <a:cs typeface="Calibri" pitchFamily="34" charset="-120"/>
               </a:rPr>
-              <a:t>por e-mail</a:t>
-            </a:r>
-            <a:endParaRPr lang="en-US" sz="1250" dirty="0"/>
-          </a:p>
-        </p:txBody>
-      </p:sp>
-      <p:sp>
-        <p:nvSpPr>
-          <p:cNvPr id="11" name="Shape 9"/>
-          <p:cNvSpPr/>
-          <p:nvPr/>
-        </p:nvSpPr>
-        <p:spPr>
-          <a:xfrm>
-            <a:off x="7964424" y="2212848"/>
-            <a:ext cx="3310128" cy="2834640"/>
-          </a:xfrm>
-          <a:prstGeom prst="roundRect">
-            <a:avLst>
-              <a:gd name="adj" fmla="val 1935"/>
-            </a:avLst>
-          </a:prstGeom>
-          <a:solidFill>
-            <a:srgbClr val="13101D"/>
-          </a:solidFill>
-          <a:ln w="12700">
-            <a:solidFill>
-              <a:srgbClr val="2A2440"/>
-            </a:solidFill>
-            <a:prstDash val="dash"/>
-          </a:ln>
-        </p:spPr>
-      </p:sp>
-      <p:sp>
-        <p:nvSpPr>
-          <p:cNvPr id="12" name="Text 10"/>
-          <p:cNvSpPr txBox="1"/>
-          <p:nvPr/>
-        </p:nvSpPr>
-        <p:spPr>
-          <a:xfrm>
-            <a:off x="8129016" y="3246120"/>
-            <a:ext cx="2980944" cy="768096"/>
+              <a:t>QR Code e PDF</a:t>
+            </a:r>
+            <a:endParaRPr lang="en-US" sz="1200" dirty="0"/>
+          </a:p>
+        </p:txBody>
+      </p:sp>
+      <p:sp>
+        <p:nvSpPr>
+          <p:cNvPr id="14" name="Text 9"/>
+          <p:cNvSpPr txBox="1"/>
+          <p:nvPr/>
+        </p:nvSpPr>
+        <p:spPr>
+          <a:xfrm>
+            <a:off x="685800" y="6254496"/>
+            <a:ext cx="10607040" cy="274320"/>
           </a:xfrm>
           <a:prstGeom prst="rect">
             <a:avLst/>
@@ -4305,14 +4340,11 @@
           <a:bodyPr wrap="square" lIns="0" tIns="0" rIns="0" bIns="0" rtlCol="0" anchor="ctr"/>
           <a:lstStyle/>
           <a:p>
-            <a:pPr algn="ctr" indent="0" marL="0">
-              <a:lnSpc>
-                <a:spcPct val="120000"/>
-              </a:lnSpc>
-              <a:buNone/>
-            </a:pPr>
-            <a:r>
-              <a:rPr lang="en-US" sz="1150" dirty="0">
+            <a:pPr indent="0" marL="0">
+              <a:buNone/>
+            </a:pPr>
+            <a:r>
+              <a:rPr lang="en-US" sz="1000" dirty="0">
                 <a:solidFill>
                   <a:srgbClr val="6E6689"/>
                 </a:solidFill>
@@ -4320,116 +4352,15 @@
                 <a:ea typeface="Calibri" pitchFamily="34" charset="-122"/>
                 <a:cs typeface="Calibri" pitchFamily="34" charset="-120"/>
               </a:rPr>
-              <a:t>inserir print 3</a:t>
-            </a:r>
-            <a:endParaRPr lang="en-US" sz="1150" dirty="0"/>
-          </a:p>
-        </p:txBody>
-      </p:sp>
-      <p:sp>
-        <p:nvSpPr>
-          <p:cNvPr id="13" name="Text 11"/>
-          <p:cNvSpPr txBox="1"/>
-          <p:nvPr/>
-        </p:nvSpPr>
-        <p:spPr>
-          <a:xfrm>
-            <a:off x="7964424" y="5175504"/>
-            <a:ext cx="3310128" cy="566928"/>
-          </a:xfrm>
-          <a:prstGeom prst="rect">
-            <a:avLst/>
-          </a:prstGeom>
-          <a:noFill/>
-          <a:ln/>
-        </p:spPr>
-        <p:txBody>
-          <a:bodyPr wrap="square" lIns="0" tIns="0" rIns="0" bIns="0" rtlCol="0" anchor="ctr"/>
-          <a:lstStyle/>
-          <a:p>
-            <a:pPr indent="0" marL="0">
-              <a:lnSpc>
-                <a:spcPct val="120000"/>
-              </a:lnSpc>
-              <a:buNone/>
-            </a:pPr>
-            <a:r>
-              <a:rPr lang="en-US" sz="1250" dirty="0">
-                <a:solidFill>
-                  <a:srgbClr val="F5F2FF"/>
-                </a:solidFill>
-                <a:latin typeface="Calibri" pitchFamily="34" charset="0"/>
-                <a:ea typeface="Calibri" pitchFamily="34" charset="-122"/>
-                <a:cs typeface="Calibri" pitchFamily="34" charset="-120"/>
-              </a:rPr>
-              <a:t>Ingresso digital com</a:t>
-            </a:r>
-            <a:endParaRPr lang="en-US" sz="1250" dirty="0"/>
-          </a:p>
-          <a:p>
-            <a:pPr indent="0" marL="0">
-              <a:lnSpc>
-                <a:spcPct val="120000"/>
-              </a:lnSpc>
-              <a:buNone/>
-            </a:pPr>
-            <a:r>
-              <a:rPr lang="en-US" sz="1250" dirty="0">
-                <a:solidFill>
-                  <a:srgbClr val="F5F2FF"/>
-                </a:solidFill>
-                <a:latin typeface="Calibri" pitchFamily="34" charset="0"/>
-                <a:ea typeface="Calibri" pitchFamily="34" charset="-122"/>
-                <a:cs typeface="Calibri" pitchFamily="34" charset="-120"/>
-              </a:rPr>
-              <a:t>QR Code e PDF</a:t>
-            </a:r>
-            <a:endParaRPr lang="en-US" sz="1250" dirty="0"/>
-          </a:p>
-        </p:txBody>
-      </p:sp>
-      <p:sp>
-        <p:nvSpPr>
-          <p:cNvPr id="14" name="Text 12"/>
-          <p:cNvSpPr txBox="1"/>
-          <p:nvPr/>
-        </p:nvSpPr>
-        <p:spPr>
-          <a:xfrm>
-            <a:off x="685800" y="6291072"/>
-            <a:ext cx="8229600" cy="274320"/>
-          </a:xfrm>
-          <a:prstGeom prst="rect">
-            <a:avLst/>
-          </a:prstGeom>
-          <a:noFill/>
-          <a:ln/>
-        </p:spPr>
-        <p:txBody>
-          <a:bodyPr wrap="square" lIns="0" tIns="0" rIns="0" bIns="0" rtlCol="0" anchor="ctr"/>
-          <a:lstStyle/>
-          <a:p>
-            <a:pPr indent="0" marL="0">
-              <a:buNone/>
-            </a:pPr>
-            <a:r>
-              <a:rPr lang="en-US" sz="1050" dirty="0">
-                <a:solidFill>
-                  <a:srgbClr val="6E6689"/>
-                </a:solidFill>
-                <a:latin typeface="Calibri" pitchFamily="34" charset="0"/>
-                <a:ea typeface="Calibri" pitchFamily="34" charset="-122"/>
-                <a:cs typeface="Calibri" pitchFamily="34" charset="-120"/>
-              </a:rPr>
-              <a:t>Prints do produto. Dados demonstrativos, sem dados pessoais e sem QR Code válido.</a:t>
-            </a:r>
-            <a:endParaRPr lang="en-US" sz="1050" dirty="0"/>
-          </a:p>
-        </p:txBody>
-      </p:sp>
-      <p:sp>
-        <p:nvSpPr>
-          <p:cNvPr id="15" name="Text 13"/>
+              <a:t>Prints do evento demonstrativo. Dados e valores fictícios; os dados pessoais do comprador ficaram fora do enquadramento e o QR Code foi substituído por um código sem validade.</a:t>
+            </a:r>
+            <a:endParaRPr lang="en-US" sz="1000" dirty="0"/>
+          </a:p>
+        </p:txBody>
+      </p:sp>
+      <p:sp>
+        <p:nvSpPr>
+          <p:cNvPr id="15" name="Text 10"/>
           <p:cNvSpPr txBox="1"/>
           <p:nvPr/>
         </p:nvSpPr>
@@ -4579,98 +4510,55 @@
           </a:p>
         </p:txBody>
       </p:sp>
-      <p:sp>
-        <p:nvSpPr>
-          <p:cNvPr id="4" name="Shape 2"/>
+      <p:pic>
+        <p:nvPicPr>
+          <p:cNvPr id="4" name="Image 0" descr="shots/c_checkin.png">    </p:cNvPr>
+          <p:cNvPicPr>
+            <a:picLocks noChangeAspect="1"/>
+          </p:cNvPicPr>
+          <p:nvPr/>
+        </p:nvPicPr>
+        <p:blipFill>
+          <a:blip r:embed="rId1"/>
+          <a:stretch>
+            <a:fillRect/>
+          </a:stretch>
+        </p:blipFill>
+        <p:spPr>
+          <a:xfrm>
+            <a:off x="685800" y="2148840"/>
+            <a:ext cx="5989320" cy="3739896"/>
+          </a:xfrm>
+          <a:prstGeom prst="rect">
+            <a:avLst/>
+          </a:prstGeom>
+        </p:spPr>
+      </p:pic>
+      <p:sp>
+        <p:nvSpPr>
+          <p:cNvPr id="5" name="Shape 2"/>
           <p:cNvSpPr/>
           <p:nvPr/>
         </p:nvSpPr>
         <p:spPr>
           <a:xfrm>
             <a:off x="685800" y="2148840"/>
-            <a:ext cx="5989320" cy="3749040"/>
-          </a:xfrm>
-          <a:prstGeom prst="roundRect">
-            <a:avLst>
-              <a:gd name="adj" fmla="val 1463"/>
-            </a:avLst>
-          </a:prstGeom>
-          <a:solidFill>
-            <a:srgbClr val="13101D"/>
-          </a:solidFill>
+            <a:ext cx="5989320" cy="3739896"/>
+          </a:xfrm>
+          <a:prstGeom prst="rect">
+            <a:avLst/>
+          </a:prstGeom>
           <a:ln w="12700">
             <a:solidFill>
-              <a:srgbClr val="2A2440"/>
+              <a:srgbClr val="2E2552"/>
             </a:solidFill>
-            <a:prstDash val="dash"/>
+            <a:prstDash val="solid"/>
           </a:ln>
         </p:spPr>
       </p:sp>
       <p:sp>
         <p:nvSpPr>
-          <p:cNvPr id="5" name="Text 3"/>
-          <p:cNvSpPr txBox="1"/>
-          <p:nvPr/>
-        </p:nvSpPr>
-        <p:spPr>
-          <a:xfrm>
-            <a:off x="850392" y="3639312"/>
-            <a:ext cx="5660136" cy="768096"/>
-          </a:xfrm>
-          <a:prstGeom prst="rect">
-            <a:avLst/>
-          </a:prstGeom>
-          <a:noFill/>
-          <a:ln/>
-        </p:spPr>
-        <p:txBody>
-          <a:bodyPr wrap="square" lIns="0" tIns="0" rIns="0" bIns="0" rtlCol="0" anchor="ctr"/>
-          <a:lstStyle/>
-          <a:p>
-            <a:pPr algn="ctr" indent="0" marL="0">
-              <a:lnSpc>
-                <a:spcPct val="120000"/>
-              </a:lnSpc>
-              <a:buNone/>
-            </a:pPr>
-            <a:r>
-              <a:rPr lang="en-US" sz="1150" dirty="0">
-                <a:solidFill>
-                  <a:srgbClr val="6E6689"/>
-                </a:solidFill>
-                <a:latin typeface="Calibri" pitchFamily="34" charset="0"/>
-                <a:ea typeface="Calibri" pitchFamily="34" charset="-122"/>
-                <a:cs typeface="Calibri" pitchFamily="34" charset="-120"/>
-              </a:rPr>
-              <a:t>inserir print: tela de check-in</a:t>
-            </a:r>
-            <a:endParaRPr lang="en-US" sz="1150" dirty="0"/>
-          </a:p>
-          <a:p>
-            <a:pPr algn="ctr" indent="0" marL="0">
-              <a:lnSpc>
-                <a:spcPct val="120000"/>
-              </a:lnSpc>
-              <a:buNone/>
-            </a:pPr>
-            <a:r>
-              <a:rPr lang="en-US" sz="1150" dirty="0">
-                <a:solidFill>
-                  <a:srgbClr val="6E6689"/>
-                </a:solidFill>
-                <a:latin typeface="Calibri" pitchFamily="34" charset="0"/>
-                <a:ea typeface="Calibri" pitchFamily="34" charset="-122"/>
-                <a:cs typeface="Calibri" pitchFamily="34" charset="-120"/>
-              </a:rPr>
-              <a:t>(leitura válida e tentativa duplicada)</a:t>
-            </a:r>
-            <a:endParaRPr lang="en-US" sz="1150" dirty="0"/>
-          </a:p>
-        </p:txBody>
-      </p:sp>
-      <p:sp>
-        <p:nvSpPr>
-          <p:cNvPr id="6" name="Shape 4"/>
+          <p:cNvPr id="6" name="Shape 3"/>
           <p:cNvSpPr/>
           <p:nvPr/>
         </p:nvSpPr>
@@ -4695,7 +4583,7 @@
       </p:sp>
       <p:sp>
         <p:nvSpPr>
-          <p:cNvPr id="7" name="Text 5"/>
+          <p:cNvPr id="7" name="Text 4"/>
           <p:cNvSpPr txBox="1"/>
           <p:nvPr/>
         </p:nvSpPr>
@@ -4734,7 +4622,7 @@
       </p:sp>
       <p:sp>
         <p:nvSpPr>
-          <p:cNvPr id="8" name="Text 6"/>
+          <p:cNvPr id="8" name="Text 5"/>
           <p:cNvSpPr txBox="1"/>
           <p:nvPr/>
         </p:nvSpPr>
@@ -4776,7 +4664,7 @@
       </p:sp>
       <p:sp>
         <p:nvSpPr>
-          <p:cNvPr id="9" name="Shape 7"/>
+          <p:cNvPr id="9" name="Shape 6"/>
           <p:cNvSpPr/>
           <p:nvPr/>
         </p:nvSpPr>
@@ -4801,7 +4689,7 @@
       </p:sp>
       <p:sp>
         <p:nvSpPr>
-          <p:cNvPr id="10" name="Text 8"/>
+          <p:cNvPr id="10" name="Text 7"/>
           <p:cNvSpPr txBox="1"/>
           <p:nvPr/>
         </p:nvSpPr>
@@ -4840,7 +4728,7 @@
       </p:sp>
       <p:sp>
         <p:nvSpPr>
-          <p:cNvPr id="11" name="Text 9"/>
+          <p:cNvPr id="11" name="Text 8"/>
           <p:cNvSpPr txBox="1"/>
           <p:nvPr/>
         </p:nvSpPr>
@@ -4874,7 +4762,7 @@
                 <a:ea typeface="Calibri" pitchFamily="34" charset="-122"/>
                 <a:cs typeface="Calibri" pitchFamily="34" charset="-120"/>
               </a:rPr>
-              <a:t>Ingresso válido, já utilizado ou inválido, na hora da leitura.</a:t>
+              <a:t>Liberado ou recusado na hora, com o motivo na tela e no histórico.</a:t>
             </a:r>
             <a:endParaRPr lang="en-US" sz="1250" dirty="0"/>
           </a:p>
@@ -4882,7 +4770,7 @@
       </p:sp>
       <p:sp>
         <p:nvSpPr>
-          <p:cNvPr id="12" name="Shape 10"/>
+          <p:cNvPr id="12" name="Shape 9"/>
           <p:cNvSpPr/>
           <p:nvPr/>
         </p:nvSpPr>
@@ -4907,7 +4795,7 @@
       </p:sp>
       <p:sp>
         <p:nvSpPr>
-          <p:cNvPr id="13" name="Text 11"/>
+          <p:cNvPr id="13" name="Text 10"/>
           <p:cNvSpPr txBox="1"/>
           <p:nvPr/>
         </p:nvSpPr>
@@ -4946,7 +4834,7 @@
       </p:sp>
       <p:sp>
         <p:nvSpPr>
-          <p:cNvPr id="14" name="Text 12"/>
+          <p:cNvPr id="14" name="Text 11"/>
           <p:cNvSpPr txBox="1"/>
           <p:nvPr/>
         </p:nvSpPr>
@@ -4988,7 +4876,7 @@
       </p:sp>
       <p:sp>
         <p:nvSpPr>
-          <p:cNvPr id="15" name="Shape 13"/>
+          <p:cNvPr id="15" name="Shape 12"/>
           <p:cNvSpPr/>
           <p:nvPr/>
         </p:nvSpPr>
@@ -5013,7 +4901,7 @@
       </p:sp>
       <p:sp>
         <p:nvSpPr>
-          <p:cNvPr id="16" name="Text 14"/>
+          <p:cNvPr id="16" name="Text 13"/>
           <p:cNvSpPr txBox="1"/>
           <p:nvPr/>
         </p:nvSpPr>
@@ -5052,7 +4940,7 @@
       </p:sp>
       <p:sp>
         <p:nvSpPr>
-          <p:cNvPr id="17" name="Text 15"/>
+          <p:cNvPr id="17" name="Text 14"/>
           <p:cNvSpPr txBox="1"/>
           <p:nvPr/>
         </p:nvSpPr>
@@ -5094,14 +4982,14 @@
       </p:sp>
       <p:pic>
         <p:nvPicPr>
-          <p:cNvPr id="18" name="Image 0" descr="assets/eventflow_roxo_branco_transparente.png">    </p:cNvPr>
+          <p:cNvPr id="18" name="Image 1" descr="assets/eventflow_roxo_branco_transparente.png">    </p:cNvPr>
           <p:cNvPicPr>
             <a:picLocks noChangeAspect="1"/>
           </p:cNvPicPr>
           <p:nvPr/>
         </p:nvPicPr>
         <p:blipFill>
-          <a:blip r:embed="rId1"/>
+          <a:blip r:embed="rId2"/>
           <a:stretch>
             <a:fillRect/>
           </a:stretch>
@@ -5118,7 +5006,7 @@
       </p:pic>
       <p:sp>
         <p:nvSpPr>
-          <p:cNvPr id="19" name="Text 16"/>
+          <p:cNvPr id="19" name="Text 15"/>
           <p:cNvSpPr txBox="1"/>
           <p:nvPr/>
         </p:nvSpPr>
@@ -5652,117 +5540,9 @@
           </a:p>
         </p:txBody>
       </p:sp>
-      <p:sp>
-        <p:nvSpPr>
-          <p:cNvPr id="16" name="Shape 14"/>
-          <p:cNvSpPr/>
-          <p:nvPr/>
-        </p:nvSpPr>
-        <p:spPr>
-          <a:xfrm>
-            <a:off x="4892040" y="2148840"/>
-            <a:ext cx="6583680" cy="3657600"/>
-          </a:xfrm>
-          <a:prstGeom prst="roundRect">
-            <a:avLst>
-              <a:gd name="adj" fmla="val 1500"/>
-            </a:avLst>
-          </a:prstGeom>
-          <a:solidFill>
-            <a:srgbClr val="13101D"/>
-          </a:solidFill>
-          <a:ln w="12700">
-            <a:solidFill>
-              <a:srgbClr val="2A2440"/>
-            </a:solidFill>
-            <a:prstDash val="dash"/>
-          </a:ln>
-        </p:spPr>
-      </p:sp>
-      <p:sp>
-        <p:nvSpPr>
-          <p:cNvPr id="17" name="Text 15"/>
-          <p:cNvSpPr txBox="1"/>
-          <p:nvPr/>
-        </p:nvSpPr>
-        <p:spPr>
-          <a:xfrm>
-            <a:off x="5056632" y="3593592"/>
-            <a:ext cx="6254496" cy="768096"/>
-          </a:xfrm>
-          <a:prstGeom prst="rect">
-            <a:avLst/>
-          </a:prstGeom>
-          <a:noFill/>
-          <a:ln/>
-        </p:spPr>
-        <p:txBody>
-          <a:bodyPr wrap="square" lIns="0" tIns="0" rIns="0" bIns="0" rtlCol="0" anchor="ctr"/>
-          <a:lstStyle/>
-          <a:p>
-            <a:pPr algn="ctr" indent="0" marL="0">
-              <a:lnSpc>
-                <a:spcPct val="120000"/>
-              </a:lnSpc>
-              <a:buNone/>
-            </a:pPr>
-            <a:r>
-              <a:rPr lang="en-US" sz="1150" dirty="0">
-                <a:solidFill>
-                  <a:srgbClr val="6E6689"/>
-                </a:solidFill>
-                <a:latin typeface="Calibri" pitchFamily="34" charset="0"/>
-                <a:ea typeface="Calibri" pitchFamily="34" charset="-122"/>
-                <a:cs typeface="Calibri" pitchFamily="34" charset="-120"/>
-              </a:rPr>
-              <a:t>inserir print: painel do organizador</a:t>
-            </a:r>
-            <a:endParaRPr lang="en-US" sz="1150" dirty="0"/>
-          </a:p>
-        </p:txBody>
-      </p:sp>
-      <p:sp>
-        <p:nvSpPr>
-          <p:cNvPr id="18" name="Text 16"/>
-          <p:cNvSpPr txBox="1"/>
-          <p:nvPr/>
-        </p:nvSpPr>
-        <p:spPr>
-          <a:xfrm>
-            <a:off x="4892040" y="5925312"/>
-            <a:ext cx="3657600" cy="274320"/>
-          </a:xfrm>
-          <a:prstGeom prst="rect">
-            <a:avLst/>
-          </a:prstGeom>
-          <a:noFill/>
-          <a:ln/>
-        </p:spPr>
-        <p:txBody>
-          <a:bodyPr wrap="square" lIns="0" tIns="0" rIns="0" bIns="0" rtlCol="0" anchor="ctr"/>
-          <a:lstStyle/>
-          <a:p>
-            <a:pPr indent="0" marL="0">
-              <a:buNone/>
-            </a:pPr>
-            <a:r>
-              <a:rPr lang="en-US" sz="1050" dirty="0">
-                <a:solidFill>
-                  <a:srgbClr val="6E6689"/>
-                </a:solidFill>
-                <a:latin typeface="Calibri" pitchFamily="34" charset="0"/>
-                <a:ea typeface="Calibri" pitchFamily="34" charset="-122"/>
-                <a:cs typeface="Calibri" pitchFamily="34" charset="-120"/>
-              </a:rPr>
-              <a:t>Dados demonstrativos.</a:t>
-            </a:r>
-            <a:endParaRPr lang="en-US" sz="1050" dirty="0"/>
-          </a:p>
-        </p:txBody>
-      </p:sp>
       <p:pic>
         <p:nvPicPr>
-          <p:cNvPr id="19" name="Image 0" descr="assets/eventflow_roxo_branco_transparente.png">    </p:cNvPr>
+          <p:cNvPr id="16" name="Image 0" descr="shots/c_dashboard.png">    </p:cNvPr>
           <p:cNvPicPr>
             <a:picLocks noChangeAspect="1"/>
           </p:cNvPicPr>
@@ -5776,6 +5556,91 @@
         </p:blipFill>
         <p:spPr>
           <a:xfrm>
+            <a:off x="4892040" y="2148840"/>
+            <a:ext cx="6583680" cy="3593592"/>
+          </a:xfrm>
+          <a:prstGeom prst="rect">
+            <a:avLst/>
+          </a:prstGeom>
+        </p:spPr>
+      </p:pic>
+      <p:sp>
+        <p:nvSpPr>
+          <p:cNvPr id="17" name="Shape 14"/>
+          <p:cNvSpPr/>
+          <p:nvPr/>
+        </p:nvSpPr>
+        <p:spPr>
+          <a:xfrm>
+            <a:off x="4892040" y="2148840"/>
+            <a:ext cx="6583680" cy="3593592"/>
+          </a:xfrm>
+          <a:prstGeom prst="rect">
+            <a:avLst/>
+          </a:prstGeom>
+          <a:ln w="12700">
+            <a:solidFill>
+              <a:srgbClr val="2E2552"/>
+            </a:solidFill>
+            <a:prstDash val="solid"/>
+          </a:ln>
+        </p:spPr>
+      </p:sp>
+      <p:sp>
+        <p:nvSpPr>
+          <p:cNvPr id="18" name="Text 15"/>
+          <p:cNvSpPr txBox="1"/>
+          <p:nvPr/>
+        </p:nvSpPr>
+        <p:spPr>
+          <a:xfrm>
+            <a:off x="4892040" y="5870448"/>
+            <a:ext cx="5486400" cy="274320"/>
+          </a:xfrm>
+          <a:prstGeom prst="rect">
+            <a:avLst/>
+          </a:prstGeom>
+          <a:noFill/>
+          <a:ln/>
+        </p:spPr>
+        <p:txBody>
+          <a:bodyPr wrap="square" lIns="0" tIns="0" rIns="0" bIns="0" rtlCol="0" anchor="ctr"/>
+          <a:lstStyle/>
+          <a:p>
+            <a:pPr indent="0" marL="0">
+              <a:buNone/>
+            </a:pPr>
+            <a:r>
+              <a:rPr lang="en-US" sz="1000" dirty="0">
+                <a:solidFill>
+                  <a:srgbClr val="6E6689"/>
+                </a:solidFill>
+                <a:latin typeface="Calibri" pitchFamily="34" charset="0"/>
+                <a:ea typeface="Calibri" pitchFamily="34" charset="-122"/>
+                <a:cs typeface="Calibri" pitchFamily="34" charset="-120"/>
+              </a:rPr>
+              <a:t>Painel real da Evenflow. Dados demonstrativos.</a:t>
+            </a:r>
+            <a:endParaRPr lang="en-US" sz="1000" dirty="0"/>
+          </a:p>
+        </p:txBody>
+      </p:sp>
+      <p:pic>
+        <p:nvPicPr>
+          <p:cNvPr id="19" name="Image 1" descr="assets/eventflow_roxo_branco_transparente.png">    </p:cNvPr>
+          <p:cNvPicPr>
+            <a:picLocks noChangeAspect="1"/>
+          </p:cNvPicPr>
+          <p:nvPr/>
+        </p:nvPicPr>
+        <p:blipFill>
+          <a:blip r:embed="rId2"/>
+          <a:stretch>
+            <a:fillRect/>
+          </a:stretch>
+        </p:blipFill>
+        <p:spPr>
+          <a:xfrm>
             <a:off x="685800" y="6291072"/>
             <a:ext cx="841248" cy="335585"/>
           </a:xfrm>
@@ -5786,7 +5651,7 @@
       </p:pic>
       <p:sp>
         <p:nvSpPr>
-          <p:cNvPr id="20" name="Text 17"/>
+          <p:cNvPr id="20" name="Text 16"/>
           <p:cNvSpPr txBox="1"/>
           <p:nvPr/>
         </p:nvSpPr>

</xml_diff>